<commit_message>
Deck polish: editorial dividers, years column, NCES latest wave, chart as image
Co-Authored-By: Claude Fable 5 <noreply@anthropic.com>
Claude-Session: https://claude.ai/code/session_01DNzQPDcr3zfLTraMHUHqUn
</commit_message>
<xml_diff>
--- a/report/Proyect_US_v3.pptx
+++ b/report/Proyect_US_v3.pptx
@@ -246,1162 +246,6 @@
     </pc:docChg>
   </pc:docChgLst>
 </pc:chgInfo>
-</file>
-
-<file path=ppt/charts/chart1.xml><?xml version="1.0" encoding="utf-8"?>
-<c:chartSpace xmlns:c="http://schemas.openxmlformats.org/drawingml/2006/chart" xmlns:a="http://schemas.openxmlformats.org/drawingml/2006/main" xmlns:r="http://schemas.openxmlformats.org/officeDocument/2006/relationships">
-  <c:date1904 val="0"/>
-  <c:chart>
-    <c:autoTitleDeleted val="1"/>
-    <c:plotArea>
-      <c:lineChart>
-        <c:grouping val="standard"/>
-        <c:varyColors val="0"/>
-        <c:ser>
-          <c:idx val="0"/>
-          <c:order val="0"/>
-          <c:tx>
-            <c:strRef>
-              <c:f>Sheet1!$B$1</c:f>
-              <c:strCache>
-                <c:ptCount val="1"/>
-                <c:pt idx="0">
-                  <c:v>March recall</c:v>
-                </c:pt>
-              </c:strCache>
-            </c:strRef>
-          </c:tx>
-          <c:spPr>
-            <a:ln w="34925">
-              <a:solidFill>
-                <a:srgbClr val="1F4E79"/>
-              </a:solidFill>
-            </a:ln>
-          </c:spPr>
-          <c:marker>
-            <c:symbol val="none"/>
-          </c:marker>
-          <c:cat>
-            <c:strRef>
-              <c:f>Sheet1!$A$2:$A$38</c:f>
-              <c:strCache>
-                <c:ptCount val="37"/>
-                <c:pt idx="0">
-                  <c:v>1988</c:v>
-                </c:pt>
-                <c:pt idx="1">
-                  <c:v>1989</c:v>
-                </c:pt>
-                <c:pt idx="2">
-                  <c:v>1990</c:v>
-                </c:pt>
-                <c:pt idx="3">
-                  <c:v>1991</c:v>
-                </c:pt>
-                <c:pt idx="4">
-                  <c:v>1992</c:v>
-                </c:pt>
-                <c:pt idx="5">
-                  <c:v>1993</c:v>
-                </c:pt>
-                <c:pt idx="6">
-                  <c:v>1994</c:v>
-                </c:pt>
-                <c:pt idx="7">
-                  <c:v>1995</c:v>
-                </c:pt>
-                <c:pt idx="8">
-                  <c:v>1996</c:v>
-                </c:pt>
-                <c:pt idx="9">
-                  <c:v>1997</c:v>
-                </c:pt>
-                <c:pt idx="10">
-                  <c:v>1998</c:v>
-                </c:pt>
-                <c:pt idx="11">
-                  <c:v>1999</c:v>
-                </c:pt>
-                <c:pt idx="12">
-                  <c:v>2000</c:v>
-                </c:pt>
-                <c:pt idx="13">
-                  <c:v>2001</c:v>
-                </c:pt>
-                <c:pt idx="14">
-                  <c:v>2002</c:v>
-                </c:pt>
-                <c:pt idx="15">
-                  <c:v>2003</c:v>
-                </c:pt>
-                <c:pt idx="16">
-                  <c:v>2004</c:v>
-                </c:pt>
-                <c:pt idx="17">
-                  <c:v>2005</c:v>
-                </c:pt>
-                <c:pt idx="18">
-                  <c:v>2006</c:v>
-                </c:pt>
-                <c:pt idx="19">
-                  <c:v>2007</c:v>
-                </c:pt>
-                <c:pt idx="20">
-                  <c:v>2008</c:v>
-                </c:pt>
-                <c:pt idx="21">
-                  <c:v>2009</c:v>
-                </c:pt>
-                <c:pt idx="22">
-                  <c:v>2010</c:v>
-                </c:pt>
-                <c:pt idx="23">
-                  <c:v>2011</c:v>
-                </c:pt>
-                <c:pt idx="24">
-                  <c:v>2012</c:v>
-                </c:pt>
-                <c:pt idx="25">
-                  <c:v>2013</c:v>
-                </c:pt>
-                <c:pt idx="26">
-                  <c:v>2014</c:v>
-                </c:pt>
-                <c:pt idx="27">
-                  <c:v>2015</c:v>
-                </c:pt>
-                <c:pt idx="28">
-                  <c:v>2016</c:v>
-                </c:pt>
-                <c:pt idx="29">
-                  <c:v>2017</c:v>
-                </c:pt>
-                <c:pt idx="30">
-                  <c:v>2018</c:v>
-                </c:pt>
-                <c:pt idx="31">
-                  <c:v>2019</c:v>
-                </c:pt>
-                <c:pt idx="32">
-                  <c:v>2020</c:v>
-                </c:pt>
-                <c:pt idx="33">
-                  <c:v>2021</c:v>
-                </c:pt>
-                <c:pt idx="34">
-                  <c:v>2022</c:v>
-                </c:pt>
-                <c:pt idx="35">
-                  <c:v>2023</c:v>
-                </c:pt>
-                <c:pt idx="36">
-                  <c:v>2024</c:v>
-                </c:pt>
-              </c:strCache>
-            </c:strRef>
-          </c:cat>
-          <c:val>
-            <c:numRef>
-              <c:f>Sheet1!$B$2:$B$38</c:f>
-              <c:numCache>
-                <c:formatCode>General</c:formatCode>
-                <c:ptCount val="37"/>
-                <c:pt idx="9">
-                  <c:v>9.52</c:v>
-                </c:pt>
-                <c:pt idx="10">
-                  <c:v>9.21</c:v>
-                </c:pt>
-                <c:pt idx="11">
-                  <c:v>8.15</c:v>
-                </c:pt>
-                <c:pt idx="12">
-                  <c:v>8.43</c:v>
-                </c:pt>
-                <c:pt idx="13">
-                  <c:v>10.28</c:v>
-                </c:pt>
-                <c:pt idx="14">
-                  <c:v>9.28</c:v>
-                </c:pt>
-                <c:pt idx="15">
-                  <c:v>8.13</c:v>
-                </c:pt>
-                <c:pt idx="16">
-                  <c:v>8.15</c:v>
-                </c:pt>
-                <c:pt idx="17">
-                  <c:v>8.9</c:v>
-                </c:pt>
-                <c:pt idx="18">
-                  <c:v>7.61</c:v>
-                </c:pt>
-                <c:pt idx="19">
-                  <c:v>7.72</c:v>
-                </c:pt>
-                <c:pt idx="20">
-                  <c:v>8.24</c:v>
-                </c:pt>
-                <c:pt idx="21">
-                  <c:v>9.34</c:v>
-                </c:pt>
-                <c:pt idx="22">
-                  <c:v>9.05</c:v>
-                </c:pt>
-                <c:pt idx="23">
-                  <c:v>8.94</c:v>
-                </c:pt>
-                <c:pt idx="24">
-                  <c:v>9.99</c:v>
-                </c:pt>
-                <c:pt idx="25">
-                  <c:v>9.07</c:v>
-                </c:pt>
-                <c:pt idx="26">
-                  <c:v>8.28</c:v>
-                </c:pt>
-                <c:pt idx="27">
-                  <c:v>7.33</c:v>
-                </c:pt>
-                <c:pt idx="28">
-                  <c:v>8.73</c:v>
-                </c:pt>
-                <c:pt idx="29">
-                  <c:v>8.33</c:v>
-                </c:pt>
-                <c:pt idx="30">
-                  <c:v>7.52</c:v>
-                </c:pt>
-                <c:pt idx="31">
-                  <c:v>10.24</c:v>
-                </c:pt>
-                <c:pt idx="32">
-                  <c:v>9.02</c:v>
-                </c:pt>
-                <c:pt idx="33">
-                  <c:v>7.09</c:v>
-                </c:pt>
-                <c:pt idx="34">
-                  <c:v>8.33</c:v>
-                </c:pt>
-                <c:pt idx="35">
-                  <c:v>8.22</c:v>
-                </c:pt>
-                <c:pt idx="36">
-                  <c:v>7.66</c:v>
-                </c:pt>
-              </c:numCache>
-            </c:numRef>
-          </c:val>
-          <c:smooth val="0"/>
-        </c:ser>
-        <c:ser>
-          <c:idx val="1"/>
-          <c:order val="1"/>
-          <c:tx>
-            <c:strRef>
-              <c:f>Sheet1!$C$1</c:f>
-              <c:strCache>
-                <c:ptCount val="1"/>
-                <c:pt idx="0">
-                  <c:v>Panel, one verdict per teacher</c:v>
-                </c:pt>
-              </c:strCache>
-            </c:strRef>
-          </c:tx>
-          <c:spPr>
-            <a:ln w="31750">
-              <a:solidFill>
-                <a:srgbClr val="B5443C"/>
-              </a:solidFill>
-            </a:ln>
-          </c:spPr>
-          <c:marker>
-            <c:symbol val="none"/>
-          </c:marker>
-          <c:cat>
-            <c:strRef>
-              <c:f>Sheet1!$A$2:$A$38</c:f>
-              <c:strCache>
-                <c:ptCount val="37"/>
-                <c:pt idx="0">
-                  <c:v>1988</c:v>
-                </c:pt>
-                <c:pt idx="1">
-                  <c:v>1989</c:v>
-                </c:pt>
-                <c:pt idx="2">
-                  <c:v>1990</c:v>
-                </c:pt>
-                <c:pt idx="3">
-                  <c:v>1991</c:v>
-                </c:pt>
-                <c:pt idx="4">
-                  <c:v>1992</c:v>
-                </c:pt>
-                <c:pt idx="5">
-                  <c:v>1993</c:v>
-                </c:pt>
-                <c:pt idx="6">
-                  <c:v>1994</c:v>
-                </c:pt>
-                <c:pt idx="7">
-                  <c:v>1995</c:v>
-                </c:pt>
-                <c:pt idx="8">
-                  <c:v>1996</c:v>
-                </c:pt>
-                <c:pt idx="9">
-                  <c:v>1997</c:v>
-                </c:pt>
-                <c:pt idx="10">
-                  <c:v>1998</c:v>
-                </c:pt>
-                <c:pt idx="11">
-                  <c:v>1999</c:v>
-                </c:pt>
-                <c:pt idx="12">
-                  <c:v>2000</c:v>
-                </c:pt>
-                <c:pt idx="13">
-                  <c:v>2001</c:v>
-                </c:pt>
-                <c:pt idx="14">
-                  <c:v>2002</c:v>
-                </c:pt>
-                <c:pt idx="15">
-                  <c:v>2003</c:v>
-                </c:pt>
-                <c:pt idx="16">
-                  <c:v>2004</c:v>
-                </c:pt>
-                <c:pt idx="17">
-                  <c:v>2005</c:v>
-                </c:pt>
-                <c:pt idx="18">
-                  <c:v>2006</c:v>
-                </c:pt>
-                <c:pt idx="19">
-                  <c:v>2007</c:v>
-                </c:pt>
-                <c:pt idx="20">
-                  <c:v>2008</c:v>
-                </c:pt>
-                <c:pt idx="21">
-                  <c:v>2009</c:v>
-                </c:pt>
-                <c:pt idx="22">
-                  <c:v>2010</c:v>
-                </c:pt>
-                <c:pt idx="23">
-                  <c:v>2011</c:v>
-                </c:pt>
-                <c:pt idx="24">
-                  <c:v>2012</c:v>
-                </c:pt>
-                <c:pt idx="25">
-                  <c:v>2013</c:v>
-                </c:pt>
-                <c:pt idx="26">
-                  <c:v>2014</c:v>
-                </c:pt>
-                <c:pt idx="27">
-                  <c:v>2015</c:v>
-                </c:pt>
-                <c:pt idx="28">
-                  <c:v>2016</c:v>
-                </c:pt>
-                <c:pt idx="29">
-                  <c:v>2017</c:v>
-                </c:pt>
-                <c:pt idx="30">
-                  <c:v>2018</c:v>
-                </c:pt>
-                <c:pt idx="31">
-                  <c:v>2019</c:v>
-                </c:pt>
-                <c:pt idx="32">
-                  <c:v>2020</c:v>
-                </c:pt>
-                <c:pt idx="33">
-                  <c:v>2021</c:v>
-                </c:pt>
-                <c:pt idx="34">
-                  <c:v>2022</c:v>
-                </c:pt>
-                <c:pt idx="35">
-                  <c:v>2023</c:v>
-                </c:pt>
-                <c:pt idx="36">
-                  <c:v>2024</c:v>
-                </c:pt>
-              </c:strCache>
-            </c:strRef>
-          </c:cat>
-          <c:val>
-            <c:numRef>
-              <c:f>Sheet1!$C$2:$C$38</c:f>
-              <c:numCache>
-                <c:formatCode>General</c:formatCode>
-                <c:ptCount val="37"/>
-                <c:pt idx="17">
-                  <c:v>11.76</c:v>
-                </c:pt>
-                <c:pt idx="18">
-                  <c:v>12.6</c:v>
-                </c:pt>
-                <c:pt idx="19">
-                  <c:v>11.0</c:v>
-                </c:pt>
-                <c:pt idx="20">
-                  <c:v>10.63</c:v>
-                </c:pt>
-                <c:pt idx="21">
-                  <c:v>12.52</c:v>
-                </c:pt>
-                <c:pt idx="22">
-                  <c:v>11.16</c:v>
-                </c:pt>
-                <c:pt idx="23">
-                  <c:v>13.28</c:v>
-                </c:pt>
-                <c:pt idx="24">
-                  <c:v>13.3</c:v>
-                </c:pt>
-                <c:pt idx="25">
-                  <c:v>13.19</c:v>
-                </c:pt>
-                <c:pt idx="26">
-                  <c:v>13.37</c:v>
-                </c:pt>
-                <c:pt idx="27">
-                  <c:v>12.71</c:v>
-                </c:pt>
-                <c:pt idx="28">
-                  <c:v>13.45</c:v>
-                </c:pt>
-                <c:pt idx="29">
-                  <c:v>12.53</c:v>
-                </c:pt>
-                <c:pt idx="30">
-                  <c:v>13.07</c:v>
-                </c:pt>
-                <c:pt idx="31">
-                  <c:v>15.58</c:v>
-                </c:pt>
-                <c:pt idx="32">
-                  <c:v>13.3</c:v>
-                </c:pt>
-                <c:pt idx="33">
-                  <c:v>12.9</c:v>
-                </c:pt>
-                <c:pt idx="34">
-                  <c:v>14.15</c:v>
-                </c:pt>
-                <c:pt idx="35">
-                  <c:v>14.56</c:v>
-                </c:pt>
-                <c:pt idx="36">
-                  <c:v>14.09</c:v>
-                </c:pt>
-              </c:numCache>
-            </c:numRef>
-          </c:val>
-          <c:smooth val="0"/>
-        </c:ser>
-        <c:ser>
-          <c:idx val="2"/>
-          <c:order val="2"/>
-          <c:tx>
-            <c:strRef>
-              <c:f>Sheet1!$D$1</c:f>
-              <c:strCache>
-                <c:ptCount val="1"/>
-                <c:pt idx="0">
-                  <c:v>Panel, month pairs</c:v>
-                </c:pt>
-              </c:strCache>
-            </c:strRef>
-          </c:tx>
-          <c:spPr>
-            <a:ln w="19050">
-              <a:solidFill>
-                <a:srgbClr val="C9726A"/>
-              </a:solidFill>
-              <a:prstDash val="dash"/>
-            </a:ln>
-          </c:spPr>
-          <c:marker>
-            <c:symbol val="none"/>
-          </c:marker>
-          <c:cat>
-            <c:strRef>
-              <c:f>Sheet1!$A$2:$A$38</c:f>
-              <c:strCache>
-                <c:ptCount val="37"/>
-                <c:pt idx="0">
-                  <c:v>1988</c:v>
-                </c:pt>
-                <c:pt idx="1">
-                  <c:v>1989</c:v>
-                </c:pt>
-                <c:pt idx="2">
-                  <c:v>1990</c:v>
-                </c:pt>
-                <c:pt idx="3">
-                  <c:v>1991</c:v>
-                </c:pt>
-                <c:pt idx="4">
-                  <c:v>1992</c:v>
-                </c:pt>
-                <c:pt idx="5">
-                  <c:v>1993</c:v>
-                </c:pt>
-                <c:pt idx="6">
-                  <c:v>1994</c:v>
-                </c:pt>
-                <c:pt idx="7">
-                  <c:v>1995</c:v>
-                </c:pt>
-                <c:pt idx="8">
-                  <c:v>1996</c:v>
-                </c:pt>
-                <c:pt idx="9">
-                  <c:v>1997</c:v>
-                </c:pt>
-                <c:pt idx="10">
-                  <c:v>1998</c:v>
-                </c:pt>
-                <c:pt idx="11">
-                  <c:v>1999</c:v>
-                </c:pt>
-                <c:pt idx="12">
-                  <c:v>2000</c:v>
-                </c:pt>
-                <c:pt idx="13">
-                  <c:v>2001</c:v>
-                </c:pt>
-                <c:pt idx="14">
-                  <c:v>2002</c:v>
-                </c:pt>
-                <c:pt idx="15">
-                  <c:v>2003</c:v>
-                </c:pt>
-                <c:pt idx="16">
-                  <c:v>2004</c:v>
-                </c:pt>
-                <c:pt idx="17">
-                  <c:v>2005</c:v>
-                </c:pt>
-                <c:pt idx="18">
-                  <c:v>2006</c:v>
-                </c:pt>
-                <c:pt idx="19">
-                  <c:v>2007</c:v>
-                </c:pt>
-                <c:pt idx="20">
-                  <c:v>2008</c:v>
-                </c:pt>
-                <c:pt idx="21">
-                  <c:v>2009</c:v>
-                </c:pt>
-                <c:pt idx="22">
-                  <c:v>2010</c:v>
-                </c:pt>
-                <c:pt idx="23">
-                  <c:v>2011</c:v>
-                </c:pt>
-                <c:pt idx="24">
-                  <c:v>2012</c:v>
-                </c:pt>
-                <c:pt idx="25">
-                  <c:v>2013</c:v>
-                </c:pt>
-                <c:pt idx="26">
-                  <c:v>2014</c:v>
-                </c:pt>
-                <c:pt idx="27">
-                  <c:v>2015</c:v>
-                </c:pt>
-                <c:pt idx="28">
-                  <c:v>2016</c:v>
-                </c:pt>
-                <c:pt idx="29">
-                  <c:v>2017</c:v>
-                </c:pt>
-                <c:pt idx="30">
-                  <c:v>2018</c:v>
-                </c:pt>
-                <c:pt idx="31">
-                  <c:v>2019</c:v>
-                </c:pt>
-                <c:pt idx="32">
-                  <c:v>2020</c:v>
-                </c:pt>
-                <c:pt idx="33">
-                  <c:v>2021</c:v>
-                </c:pt>
-                <c:pt idx="34">
-                  <c:v>2022</c:v>
-                </c:pt>
-                <c:pt idx="35">
-                  <c:v>2023</c:v>
-                </c:pt>
-                <c:pt idx="36">
-                  <c:v>2024</c:v>
-                </c:pt>
-              </c:strCache>
-            </c:strRef>
-          </c:cat>
-          <c:val>
-            <c:numRef>
-              <c:f>Sheet1!$D$2:$D$38</c:f>
-              <c:numCache>
-                <c:formatCode>General</c:formatCode>
-                <c:ptCount val="37"/>
-                <c:pt idx="17">
-                  <c:v>13.36</c:v>
-                </c:pt>
-                <c:pt idx="18">
-                  <c:v>14.24</c:v>
-                </c:pt>
-                <c:pt idx="19">
-                  <c:v>12.59</c:v>
-                </c:pt>
-                <c:pt idx="20">
-                  <c:v>13.26</c:v>
-                </c:pt>
-                <c:pt idx="21">
-                  <c:v>13.51</c:v>
-                </c:pt>
-                <c:pt idx="22">
-                  <c:v>13.96</c:v>
-                </c:pt>
-                <c:pt idx="23">
-                  <c:v>14.79</c:v>
-                </c:pt>
-                <c:pt idx="24">
-                  <c:v>14.45</c:v>
-                </c:pt>
-                <c:pt idx="25">
-                  <c:v>15.05</c:v>
-                </c:pt>
-                <c:pt idx="26">
-                  <c:v>15.33</c:v>
-                </c:pt>
-                <c:pt idx="27">
-                  <c:v>15.43</c:v>
-                </c:pt>
-                <c:pt idx="28">
-                  <c:v>16.17</c:v>
-                </c:pt>
-                <c:pt idx="29">
-                  <c:v>15.71</c:v>
-                </c:pt>
-                <c:pt idx="30">
-                  <c:v>15.58</c:v>
-                </c:pt>
-                <c:pt idx="31">
-                  <c:v>18.58</c:v>
-                </c:pt>
-                <c:pt idx="32">
-                  <c:v>16.71</c:v>
-                </c:pt>
-                <c:pt idx="33">
-                  <c:v>15.95</c:v>
-                </c:pt>
-                <c:pt idx="34">
-                  <c:v>18.19</c:v>
-                </c:pt>
-                <c:pt idx="35">
-                  <c:v>16.9</c:v>
-                </c:pt>
-                <c:pt idx="36">
-                  <c:v>17.63</c:v>
-                </c:pt>
-              </c:numCache>
-            </c:numRef>
-          </c:val>
-          <c:smooth val="0"/>
-        </c:ser>
-        <c:ser>
-          <c:idx val="3"/>
-          <c:order val="3"/>
-          <c:tx>
-            <c:strRef>
-              <c:f>Sheet1!$E$1</c:f>
-              <c:strCache>
-                <c:ptCount val="1"/>
-                <c:pt idx="0">
-                  <c:v>Panel, any sighting</c:v>
-                </c:pt>
-              </c:strCache>
-            </c:strRef>
-          </c:tx>
-          <c:spPr>
-            <a:ln w="19050">
-              <a:solidFill>
-                <a:srgbClr val="D99A94"/>
-              </a:solidFill>
-            </a:ln>
-          </c:spPr>
-          <c:marker>
-            <c:symbol val="none"/>
-          </c:marker>
-          <c:cat>
-            <c:strRef>
-              <c:f>Sheet1!$A$2:$A$38</c:f>
-              <c:strCache>
-                <c:ptCount val="37"/>
-                <c:pt idx="0">
-                  <c:v>1988</c:v>
-                </c:pt>
-                <c:pt idx="1">
-                  <c:v>1989</c:v>
-                </c:pt>
-                <c:pt idx="2">
-                  <c:v>1990</c:v>
-                </c:pt>
-                <c:pt idx="3">
-                  <c:v>1991</c:v>
-                </c:pt>
-                <c:pt idx="4">
-                  <c:v>1992</c:v>
-                </c:pt>
-                <c:pt idx="5">
-                  <c:v>1993</c:v>
-                </c:pt>
-                <c:pt idx="6">
-                  <c:v>1994</c:v>
-                </c:pt>
-                <c:pt idx="7">
-                  <c:v>1995</c:v>
-                </c:pt>
-                <c:pt idx="8">
-                  <c:v>1996</c:v>
-                </c:pt>
-                <c:pt idx="9">
-                  <c:v>1997</c:v>
-                </c:pt>
-                <c:pt idx="10">
-                  <c:v>1998</c:v>
-                </c:pt>
-                <c:pt idx="11">
-                  <c:v>1999</c:v>
-                </c:pt>
-                <c:pt idx="12">
-                  <c:v>2000</c:v>
-                </c:pt>
-                <c:pt idx="13">
-                  <c:v>2001</c:v>
-                </c:pt>
-                <c:pt idx="14">
-                  <c:v>2002</c:v>
-                </c:pt>
-                <c:pt idx="15">
-                  <c:v>2003</c:v>
-                </c:pt>
-                <c:pt idx="16">
-                  <c:v>2004</c:v>
-                </c:pt>
-                <c:pt idx="17">
-                  <c:v>2005</c:v>
-                </c:pt>
-                <c:pt idx="18">
-                  <c:v>2006</c:v>
-                </c:pt>
-                <c:pt idx="19">
-                  <c:v>2007</c:v>
-                </c:pt>
-                <c:pt idx="20">
-                  <c:v>2008</c:v>
-                </c:pt>
-                <c:pt idx="21">
-                  <c:v>2009</c:v>
-                </c:pt>
-                <c:pt idx="22">
-                  <c:v>2010</c:v>
-                </c:pt>
-                <c:pt idx="23">
-                  <c:v>2011</c:v>
-                </c:pt>
-                <c:pt idx="24">
-                  <c:v>2012</c:v>
-                </c:pt>
-                <c:pt idx="25">
-                  <c:v>2013</c:v>
-                </c:pt>
-                <c:pt idx="26">
-                  <c:v>2014</c:v>
-                </c:pt>
-                <c:pt idx="27">
-                  <c:v>2015</c:v>
-                </c:pt>
-                <c:pt idx="28">
-                  <c:v>2016</c:v>
-                </c:pt>
-                <c:pt idx="29">
-                  <c:v>2017</c:v>
-                </c:pt>
-                <c:pt idx="30">
-                  <c:v>2018</c:v>
-                </c:pt>
-                <c:pt idx="31">
-                  <c:v>2019</c:v>
-                </c:pt>
-                <c:pt idx="32">
-                  <c:v>2020</c:v>
-                </c:pt>
-                <c:pt idx="33">
-                  <c:v>2021</c:v>
-                </c:pt>
-                <c:pt idx="34">
-                  <c:v>2022</c:v>
-                </c:pt>
-                <c:pt idx="35">
-                  <c:v>2023</c:v>
-                </c:pt>
-                <c:pt idx="36">
-                  <c:v>2024</c:v>
-                </c:pt>
-              </c:strCache>
-            </c:strRef>
-          </c:cat>
-          <c:val>
-            <c:numRef>
-              <c:f>Sheet1!$E$2:$E$38</c:f>
-              <c:numCache>
-                <c:formatCode>General</c:formatCode>
-                <c:ptCount val="37"/>
-                <c:pt idx="17">
-                  <c:v>15.36</c:v>
-                </c:pt>
-                <c:pt idx="18">
-                  <c:v>16.71</c:v>
-                </c:pt>
-                <c:pt idx="19">
-                  <c:v>15.39</c:v>
-                </c:pt>
-                <c:pt idx="20">
-                  <c:v>14.53</c:v>
-                </c:pt>
-                <c:pt idx="21">
-                  <c:v>17.17</c:v>
-                </c:pt>
-                <c:pt idx="22">
-                  <c:v>15.54</c:v>
-                </c:pt>
-                <c:pt idx="23">
-                  <c:v>17.67</c:v>
-                </c:pt>
-                <c:pt idx="24">
-                  <c:v>17.76</c:v>
-                </c:pt>
-                <c:pt idx="25">
-                  <c:v>18.1</c:v>
-                </c:pt>
-                <c:pt idx="26">
-                  <c:v>18.15</c:v>
-                </c:pt>
-                <c:pt idx="27">
-                  <c:v>18.15</c:v>
-                </c:pt>
-                <c:pt idx="28">
-                  <c:v>18.81</c:v>
-                </c:pt>
-                <c:pt idx="29">
-                  <c:v>18.73</c:v>
-                </c:pt>
-                <c:pt idx="30">
-                  <c:v>17.77</c:v>
-                </c:pt>
-                <c:pt idx="31">
-                  <c:v>21.81</c:v>
-                </c:pt>
-                <c:pt idx="32">
-                  <c:v>19.04</c:v>
-                </c:pt>
-                <c:pt idx="33">
-                  <c:v>19.42</c:v>
-                </c:pt>
-                <c:pt idx="34">
-                  <c:v>20.38</c:v>
-                </c:pt>
-                <c:pt idx="35">
-                  <c:v>20.41</c:v>
-                </c:pt>
-                <c:pt idx="36">
-                  <c:v>20.82</c:v>
-                </c:pt>
-              </c:numCache>
-            </c:numRef>
-          </c:val>
-          <c:smooth val="0"/>
-        </c:ser>
-        <c:ser>
-          <c:idx val="4"/>
-          <c:order val="4"/>
-          <c:tx>
-            <c:strRef>
-              <c:f>Sheet1!$F$1</c:f>
-              <c:strCache>
-                <c:ptCount val="1"/>
-                <c:pt idx="0">
-                  <c:v>NCES follow-up (public schools)</c:v>
-                </c:pt>
-              </c:strCache>
-            </c:strRef>
-          </c:tx>
-          <c:spPr>
-            <a:ln w="22225">
-              <a:solidFill>
-                <a:srgbClr val="1A2430"/>
-              </a:solidFill>
-              <a:prstDash val="dash"/>
-            </a:ln>
-          </c:spPr>
-          <c:marker>
-            <c:symbol val="circle"/>
-            <c:size val="6"/>
-          </c:marker>
-          <c:marker>
-            <c:symbol val="none"/>
-          </c:marker>
-          <c:cat>
-            <c:strRef>
-              <c:f>Sheet1!$A$2:$A$38</c:f>
-              <c:strCache>
-                <c:ptCount val="37"/>
-                <c:pt idx="0">
-                  <c:v>1988</c:v>
-                </c:pt>
-                <c:pt idx="1">
-                  <c:v>1989</c:v>
-                </c:pt>
-                <c:pt idx="2">
-                  <c:v>1990</c:v>
-                </c:pt>
-                <c:pt idx="3">
-                  <c:v>1991</c:v>
-                </c:pt>
-                <c:pt idx="4">
-                  <c:v>1992</c:v>
-                </c:pt>
-                <c:pt idx="5">
-                  <c:v>1993</c:v>
-                </c:pt>
-                <c:pt idx="6">
-                  <c:v>1994</c:v>
-                </c:pt>
-                <c:pt idx="7">
-                  <c:v>1995</c:v>
-                </c:pt>
-                <c:pt idx="8">
-                  <c:v>1996</c:v>
-                </c:pt>
-                <c:pt idx="9">
-                  <c:v>1997</c:v>
-                </c:pt>
-                <c:pt idx="10">
-                  <c:v>1998</c:v>
-                </c:pt>
-                <c:pt idx="11">
-                  <c:v>1999</c:v>
-                </c:pt>
-                <c:pt idx="12">
-                  <c:v>2000</c:v>
-                </c:pt>
-                <c:pt idx="13">
-                  <c:v>2001</c:v>
-                </c:pt>
-                <c:pt idx="14">
-                  <c:v>2002</c:v>
-                </c:pt>
-                <c:pt idx="15">
-                  <c:v>2003</c:v>
-                </c:pt>
-                <c:pt idx="16">
-                  <c:v>2004</c:v>
-                </c:pt>
-                <c:pt idx="17">
-                  <c:v>2005</c:v>
-                </c:pt>
-                <c:pt idx="18">
-                  <c:v>2006</c:v>
-                </c:pt>
-                <c:pt idx="19">
-                  <c:v>2007</c:v>
-                </c:pt>
-                <c:pt idx="20">
-                  <c:v>2008</c:v>
-                </c:pt>
-                <c:pt idx="21">
-                  <c:v>2009</c:v>
-                </c:pt>
-                <c:pt idx="22">
-                  <c:v>2010</c:v>
-                </c:pt>
-                <c:pt idx="23">
-                  <c:v>2011</c:v>
-                </c:pt>
-                <c:pt idx="24">
-                  <c:v>2012</c:v>
-                </c:pt>
-                <c:pt idx="25">
-                  <c:v>2013</c:v>
-                </c:pt>
-                <c:pt idx="26">
-                  <c:v>2014</c:v>
-                </c:pt>
-                <c:pt idx="27">
-                  <c:v>2015</c:v>
-                </c:pt>
-                <c:pt idx="28">
-                  <c:v>2016</c:v>
-                </c:pt>
-                <c:pt idx="29">
-                  <c:v>2017</c:v>
-                </c:pt>
-                <c:pt idx="30">
-                  <c:v>2018</c:v>
-                </c:pt>
-                <c:pt idx="31">
-                  <c:v>2019</c:v>
-                </c:pt>
-                <c:pt idx="32">
-                  <c:v>2020</c:v>
-                </c:pt>
-                <c:pt idx="33">
-                  <c:v>2021</c:v>
-                </c:pt>
-                <c:pt idx="34">
-                  <c:v>2022</c:v>
-                </c:pt>
-                <c:pt idx="35">
-                  <c:v>2023</c:v>
-                </c:pt>
-                <c:pt idx="36">
-                  <c:v>2024</c:v>
-                </c:pt>
-              </c:strCache>
-            </c:strRef>
-          </c:cat>
-          <c:val>
-            <c:numRef>
-              <c:f>Sheet1!$F$2:$F$38</c:f>
-              <c:numCache>
-                <c:formatCode>General</c:formatCode>
-                <c:ptCount val="37"/>
-                <c:pt idx="0">
-                  <c:v>5.6</c:v>
-                </c:pt>
-                <c:pt idx="3">
-                  <c:v>5.1</c:v>
-                </c:pt>
-                <c:pt idx="6">
-                  <c:v>6.6</c:v>
-                </c:pt>
-                <c:pt idx="12">
-                  <c:v>7.4</c:v>
-                </c:pt>
-                <c:pt idx="16">
-                  <c:v>8.4</c:v>
-                </c:pt>
-                <c:pt idx="20">
-                  <c:v>8.0</c:v>
-                </c:pt>
-                <c:pt idx="24">
-                  <c:v>7.7</c:v>
-                </c:pt>
-                <c:pt idx="33">
-                  <c:v>8.0</c:v>
-                </c:pt>
-              </c:numCache>
-            </c:numRef>
-          </c:val>
-          <c:smooth val="0"/>
-        </c:ser>
-        <c:marker val="1"/>
-        <c:smooth val="0"/>
-        <c:axId val="2118791784"/>
-        <c:axId val="2140495176"/>
-      </c:lineChart>
-      <c:catAx>
-        <c:axId val="2118791784"/>
-        <c:scaling>
-          <c:orientation val="minMax"/>
-        </c:scaling>
-        <c:delete val="0"/>
-        <c:axPos val="b"/>
-        <c:majorTickMark val="out"/>
-        <c:minorTickMark val="none"/>
-        <c:tickLblPos val="nextTo"/>
-        <c:txPr>
-          <a:bodyPr/>
-          <a:lstStyle/>
-          <a:p>
-            <a:pPr>
-              <a:defRPr sz="1000"/>
-            </a:pPr>
-          </a:p>
-        </c:txPr>
-        <c:crossAx val="2140495176"/>
-        <c:crosses val="autoZero"/>
-        <c:auto val="1"/>
-        <c:lblAlgn val="ctr"/>
-        <c:lblOffset val="100"/>
-        <c:noMultiLvlLbl val="0"/>
-      </c:catAx>
-      <c:valAx>
-        <c:axId val="2140495176"/>
-        <c:scaling>
-          <c:max val="22.0"/>
-          <c:min val="0.0"/>
-        </c:scaling>
-        <c:delete val="0"/>
-        <c:axPos val="l"/>
-        <c:majorGridlines>
-          <c:spPr>
-            <a:ln>
-              <a:solidFill>
-                <a:srgbClr val="EFF1F3"/>
-              </a:solidFill>
-            </a:ln>
-          </c:spPr>
-        </c:majorGridlines>
-        <c:majorTickMark val="out"/>
-        <c:minorTickMark val="none"/>
-        <c:tickLblPos val="nextTo"/>
-        <c:crossAx val="2118791784"/>
-        <c:crosses val="autoZero"/>
-      </c:valAx>
-    </c:plotArea>
-    <c:legend>
-      <c:legendPos val="b"/>
-      <c:layout/>
-      <c:overlay val="0"/>
-    </c:legend>
-    <c:plotVisOnly val="1"/>
-    <c:dispBlanksAs val="gap"/>
-    <c:showDLblsOverMax val="0"/>
-    <c:dispBlanksAs val="span"/>
-  </c:chart>
-  <c:txPr>
-    <a:bodyPr/>
-    <a:lstStyle/>
-    <a:p>
-      <a:pPr>
-        <a:defRPr sz="1100">
-          <a:latin typeface="Garamond"/>
-        </a:defRPr>
-      </a:pPr>
-      <a:endParaRPr lang="en-US"/>
-    </a:p>
-  </c:txPr>
-  <c:externalData r:id="rId1">
-    <c:autoUpdate val="0"/>
-  </c:externalData>
-</c:chartSpace>
 </file>
 
 <file path=ppt/notesMasters/notesMaster1.xml><?xml version="1.0" encoding="utf-8"?>
@@ -6881,51 +5725,16 @@
         <p:nvPr/>
       </p:nvGrpSpPr>
       <p:grpSpPr/>
-      <p:cxnSp>
-        <p:nvCxnSpPr>
-          <p:cNvPr id="2" name="Connector 1"/>
-          <p:cNvCxnSpPr/>
-          <p:nvPr/>
-        </p:nvCxnSpPr>
-        <p:spPr>
-          <a:xfrm>
-            <a:off x="4636008" y="2788920"/>
-            <a:ext cx="2926080" cy="0"/>
-          </a:xfrm>
-          <a:prstGeom prst="line">
-            <a:avLst/>
-          </a:prstGeom>
-          <a:ln w="9525">
-            <a:solidFill>
-              <a:srgbClr val="1A2430"/>
-            </a:solidFill>
-          </a:ln>
-        </p:spPr>
-        <p:style>
-          <a:lnRef idx="2">
-            <a:schemeClr val="accent1"/>
-          </a:lnRef>
-          <a:fillRef idx="0">
-            <a:schemeClr val="accent1"/>
-          </a:fillRef>
-          <a:effectRef idx="1">
-            <a:schemeClr val="accent1"/>
-          </a:effectRef>
-          <a:fontRef idx="minor">
-            <a:schemeClr val="tx1"/>
-          </a:fontRef>
-        </p:style>
-      </p:cxnSp>
-      <p:sp>
-        <p:nvSpPr>
-          <p:cNvPr id="3" name="TextBox 2"/>
+      <p:sp>
+        <p:nvSpPr>
+          <p:cNvPr id="2" name="TextBox 1"/>
           <p:cNvSpPr txBox="1"/>
           <p:nvPr/>
         </p:nvSpPr>
         <p:spPr>
           <a:xfrm>
-            <a:off x="4636008" y="2971800"/>
-            <a:ext cx="2926080" cy="365760"/>
+            <a:off x="1737360" y="685800"/>
+            <a:ext cx="8714232" cy="2926080"/>
           </a:xfrm>
           <a:prstGeom prst="rect">
             <a:avLst/>
@@ -6944,9 +5753,9 @@
               </a:lnSpc>
             </a:pPr>
             <a:r>
-              <a:rPr sz="1400" b="0" i="0">
-                <a:solidFill>
-                  <a:srgbClr val="55606B"/>
+              <a:rPr sz="17000" b="1" i="0">
+                <a:solidFill>
+                  <a:srgbClr val="ECF0F4"/>
                 </a:solidFill>
                 <a:latin typeface="Garamond"/>
               </a:rPr>
@@ -6957,14 +5766,14 @@
       </p:sp>
       <p:sp>
         <p:nvSpPr>
-          <p:cNvPr id="4" name="TextBox 3"/>
+          <p:cNvPr id="3" name="TextBox 2"/>
           <p:cNvSpPr txBox="1"/>
           <p:nvPr/>
         </p:nvSpPr>
         <p:spPr>
           <a:xfrm>
-            <a:off x="2807208" y="3310128"/>
-            <a:ext cx="6583680" cy="548640"/>
+            <a:off x="1737360" y="3703320"/>
+            <a:ext cx="8714232" cy="685800"/>
           </a:xfrm>
           <a:prstGeom prst="rect">
             <a:avLst/>
@@ -6983,7 +5792,7 @@
               </a:lnSpc>
             </a:pPr>
             <a:r>
-              <a:rPr sz="2600" b="0" i="0">
+              <a:rPr sz="3000" b="1" i="0">
                 <a:solidFill>
                   <a:srgbClr val="1A2430"/>
                 </a:solidFill>
@@ -6996,21 +5805,21 @@
       </p:sp>
       <p:cxnSp>
         <p:nvCxnSpPr>
-          <p:cNvPr id="5" name="Connector 4"/>
+          <p:cNvPr id="4" name="Connector 3"/>
           <p:cNvCxnSpPr/>
           <p:nvPr/>
         </p:nvCxnSpPr>
         <p:spPr>
           <a:xfrm>
-            <a:off x="4636008" y="4041648"/>
-            <a:ext cx="2926080" cy="0"/>
+            <a:off x="5367528" y="4617720"/>
+            <a:ext cx="1463040" cy="0"/>
           </a:xfrm>
           <a:prstGeom prst="line">
             <a:avLst/>
           </a:prstGeom>
-          <a:ln w="9525">
+          <a:ln w="20320">
             <a:solidFill>
-              <a:srgbClr val="1A2430"/>
+              <a:srgbClr val="1F4E79"/>
             </a:solidFill>
           </a:ln>
         </p:spPr>
@@ -7047,51 +5856,16 @@
         <p:nvPr/>
       </p:nvGrpSpPr>
       <p:grpSpPr/>
-      <p:cxnSp>
-        <p:nvCxnSpPr>
-          <p:cNvPr id="2" name="Connector 1"/>
-          <p:cNvCxnSpPr/>
-          <p:nvPr/>
-        </p:nvCxnSpPr>
-        <p:spPr>
-          <a:xfrm>
-            <a:off x="4636008" y="2788920"/>
-            <a:ext cx="2926080" cy="0"/>
-          </a:xfrm>
-          <a:prstGeom prst="line">
-            <a:avLst/>
-          </a:prstGeom>
-          <a:ln w="9525">
-            <a:solidFill>
-              <a:srgbClr val="1A2430"/>
-            </a:solidFill>
-          </a:ln>
-        </p:spPr>
-        <p:style>
-          <a:lnRef idx="2">
-            <a:schemeClr val="accent1"/>
-          </a:lnRef>
-          <a:fillRef idx="0">
-            <a:schemeClr val="accent1"/>
-          </a:fillRef>
-          <a:effectRef idx="1">
-            <a:schemeClr val="accent1"/>
-          </a:effectRef>
-          <a:fontRef idx="minor">
-            <a:schemeClr val="tx1"/>
-          </a:fontRef>
-        </p:style>
-      </p:cxnSp>
-      <p:sp>
-        <p:nvSpPr>
-          <p:cNvPr id="3" name="TextBox 2"/>
+      <p:sp>
+        <p:nvSpPr>
+          <p:cNvPr id="2" name="TextBox 1"/>
           <p:cNvSpPr txBox="1"/>
           <p:nvPr/>
         </p:nvSpPr>
         <p:spPr>
           <a:xfrm>
-            <a:off x="4636008" y="2971800"/>
-            <a:ext cx="2926080" cy="365760"/>
+            <a:off x="1737360" y="685800"/>
+            <a:ext cx="8714232" cy="2926080"/>
           </a:xfrm>
           <a:prstGeom prst="rect">
             <a:avLst/>
@@ -7110,9 +5884,9 @@
               </a:lnSpc>
             </a:pPr>
             <a:r>
-              <a:rPr sz="1400" b="0" i="0">
-                <a:solidFill>
-                  <a:srgbClr val="55606B"/>
+              <a:rPr sz="17000" b="1" i="0">
+                <a:solidFill>
+                  <a:srgbClr val="ECF0F4"/>
                 </a:solidFill>
                 <a:latin typeface="Garamond"/>
               </a:rPr>
@@ -7123,14 +5897,14 @@
       </p:sp>
       <p:sp>
         <p:nvSpPr>
-          <p:cNvPr id="4" name="TextBox 3"/>
+          <p:cNvPr id="3" name="TextBox 2"/>
           <p:cNvSpPr txBox="1"/>
           <p:nvPr/>
         </p:nvSpPr>
         <p:spPr>
           <a:xfrm>
-            <a:off x="2807208" y="3310128"/>
-            <a:ext cx="6583680" cy="548640"/>
+            <a:off x="1737360" y="3703320"/>
+            <a:ext cx="8714232" cy="685800"/>
           </a:xfrm>
           <a:prstGeom prst="rect">
             <a:avLst/>
@@ -7149,7 +5923,7 @@
               </a:lnSpc>
             </a:pPr>
             <a:r>
-              <a:rPr sz="2600" b="0" i="0">
+              <a:rPr sz="3000" b="1" i="0">
                 <a:solidFill>
                   <a:srgbClr val="1A2430"/>
                 </a:solidFill>
@@ -7162,21 +5936,21 @@
       </p:sp>
       <p:cxnSp>
         <p:nvCxnSpPr>
-          <p:cNvPr id="5" name="Connector 4"/>
+          <p:cNvPr id="4" name="Connector 3"/>
           <p:cNvCxnSpPr/>
           <p:nvPr/>
         </p:nvCxnSpPr>
         <p:spPr>
           <a:xfrm>
-            <a:off x="4636008" y="4041648"/>
-            <a:ext cx="2926080" cy="0"/>
+            <a:off x="5367528" y="4617720"/>
+            <a:ext cx="1463040" cy="0"/>
           </a:xfrm>
           <a:prstGeom prst="line">
             <a:avLst/>
           </a:prstGeom>
-          <a:ln w="9525">
+          <a:ln w="20320">
             <a:solidFill>
-              <a:srgbClr val="1A2430"/>
+              <a:srgbClr val="1F4E79"/>
             </a:solidFill>
           </a:ln>
         </p:spPr>
@@ -7810,51 +6584,16 @@
         <p:nvPr/>
       </p:nvGrpSpPr>
       <p:grpSpPr/>
-      <p:cxnSp>
-        <p:nvCxnSpPr>
-          <p:cNvPr id="2" name="Connector 1"/>
-          <p:cNvCxnSpPr/>
-          <p:nvPr/>
-        </p:nvCxnSpPr>
-        <p:spPr>
-          <a:xfrm>
-            <a:off x="4636008" y="2788920"/>
-            <a:ext cx="2926080" cy="0"/>
-          </a:xfrm>
-          <a:prstGeom prst="line">
-            <a:avLst/>
-          </a:prstGeom>
-          <a:ln w="9525">
-            <a:solidFill>
-              <a:srgbClr val="1A2430"/>
-            </a:solidFill>
-          </a:ln>
-        </p:spPr>
-        <p:style>
-          <a:lnRef idx="2">
-            <a:schemeClr val="accent1"/>
-          </a:lnRef>
-          <a:fillRef idx="0">
-            <a:schemeClr val="accent1"/>
-          </a:fillRef>
-          <a:effectRef idx="1">
-            <a:schemeClr val="accent1"/>
-          </a:effectRef>
-          <a:fontRef idx="minor">
-            <a:schemeClr val="tx1"/>
-          </a:fontRef>
-        </p:style>
-      </p:cxnSp>
-      <p:sp>
-        <p:nvSpPr>
-          <p:cNvPr id="3" name="TextBox 2"/>
+      <p:sp>
+        <p:nvSpPr>
+          <p:cNvPr id="2" name="TextBox 1"/>
           <p:cNvSpPr txBox="1"/>
           <p:nvPr/>
         </p:nvSpPr>
         <p:spPr>
           <a:xfrm>
-            <a:off x="4636008" y="2971800"/>
-            <a:ext cx="2926080" cy="365760"/>
+            <a:off x="1737360" y="685800"/>
+            <a:ext cx="8714232" cy="2926080"/>
           </a:xfrm>
           <a:prstGeom prst="rect">
             <a:avLst/>
@@ -7873,9 +6612,9 @@
               </a:lnSpc>
             </a:pPr>
             <a:r>
-              <a:rPr sz="1400" b="0" i="0">
-                <a:solidFill>
-                  <a:srgbClr val="55606B"/>
+              <a:rPr sz="17000" b="1" i="0">
+                <a:solidFill>
+                  <a:srgbClr val="ECF0F4"/>
                 </a:solidFill>
                 <a:latin typeface="Garamond"/>
               </a:rPr>
@@ -7886,14 +6625,14 @@
       </p:sp>
       <p:sp>
         <p:nvSpPr>
-          <p:cNvPr id="4" name="TextBox 3"/>
+          <p:cNvPr id="3" name="TextBox 2"/>
           <p:cNvSpPr txBox="1"/>
           <p:nvPr/>
         </p:nvSpPr>
         <p:spPr>
           <a:xfrm>
-            <a:off x="2807208" y="3310128"/>
-            <a:ext cx="6583680" cy="548640"/>
+            <a:off x="1737360" y="3703320"/>
+            <a:ext cx="8714232" cy="685800"/>
           </a:xfrm>
           <a:prstGeom prst="rect">
             <a:avLst/>
@@ -7912,7 +6651,7 @@
               </a:lnSpc>
             </a:pPr>
             <a:r>
-              <a:rPr sz="2600" b="0" i="0">
+              <a:rPr sz="3000" b="1" i="0">
                 <a:solidFill>
                   <a:srgbClr val="1A2430"/>
                 </a:solidFill>
@@ -7925,21 +6664,21 @@
       </p:sp>
       <p:cxnSp>
         <p:nvCxnSpPr>
-          <p:cNvPr id="5" name="Connector 4"/>
+          <p:cNvPr id="4" name="Connector 3"/>
           <p:cNvCxnSpPr/>
           <p:nvPr/>
         </p:nvCxnSpPr>
         <p:spPr>
           <a:xfrm>
-            <a:off x="4636008" y="4041648"/>
-            <a:ext cx="2926080" cy="0"/>
+            <a:off x="5367528" y="4617720"/>
+            <a:ext cx="1463040" cy="0"/>
           </a:xfrm>
           <a:prstGeom prst="line">
             <a:avLst/>
           </a:prstGeom>
-          <a:ln w="9525">
+          <a:ln w="20320">
             <a:solidFill>
-              <a:srgbClr val="1A2430"/>
+              <a:srgbClr val="1F4E79"/>
             </a:solidFill>
           </a:ln>
         </p:spPr>
@@ -7976,51 +6715,16 @@
         <p:nvPr/>
       </p:nvGrpSpPr>
       <p:grpSpPr/>
-      <p:cxnSp>
-        <p:nvCxnSpPr>
-          <p:cNvPr id="2" name="Connector 1"/>
-          <p:cNvCxnSpPr/>
-          <p:nvPr/>
-        </p:nvCxnSpPr>
-        <p:spPr>
-          <a:xfrm>
-            <a:off x="4636008" y="2788920"/>
-            <a:ext cx="2926080" cy="0"/>
-          </a:xfrm>
-          <a:prstGeom prst="line">
-            <a:avLst/>
-          </a:prstGeom>
-          <a:ln w="9525">
-            <a:solidFill>
-              <a:srgbClr val="1A2430"/>
-            </a:solidFill>
-          </a:ln>
-        </p:spPr>
-        <p:style>
-          <a:lnRef idx="2">
-            <a:schemeClr val="accent1"/>
-          </a:lnRef>
-          <a:fillRef idx="0">
-            <a:schemeClr val="accent1"/>
-          </a:fillRef>
-          <a:effectRef idx="1">
-            <a:schemeClr val="accent1"/>
-          </a:effectRef>
-          <a:fontRef idx="minor">
-            <a:schemeClr val="tx1"/>
-          </a:fontRef>
-        </p:style>
-      </p:cxnSp>
-      <p:sp>
-        <p:nvSpPr>
-          <p:cNvPr id="3" name="TextBox 2"/>
+      <p:sp>
+        <p:nvSpPr>
+          <p:cNvPr id="2" name="TextBox 1"/>
           <p:cNvSpPr txBox="1"/>
           <p:nvPr/>
         </p:nvSpPr>
         <p:spPr>
           <a:xfrm>
-            <a:off x="4636008" y="2971800"/>
-            <a:ext cx="2926080" cy="365760"/>
+            <a:off x="1737360" y="685800"/>
+            <a:ext cx="8714232" cy="2926080"/>
           </a:xfrm>
           <a:prstGeom prst="rect">
             <a:avLst/>
@@ -8039,9 +6743,9 @@
               </a:lnSpc>
             </a:pPr>
             <a:r>
-              <a:rPr sz="1400" b="0" i="0">
-                <a:solidFill>
-                  <a:srgbClr val="55606B"/>
+              <a:rPr sz="17000" b="1" i="0">
+                <a:solidFill>
+                  <a:srgbClr val="ECF0F4"/>
                 </a:solidFill>
                 <a:latin typeface="Garamond"/>
               </a:rPr>
@@ -8052,14 +6756,14 @@
       </p:sp>
       <p:sp>
         <p:nvSpPr>
-          <p:cNvPr id="4" name="TextBox 3"/>
+          <p:cNvPr id="3" name="TextBox 2"/>
           <p:cNvSpPr txBox="1"/>
           <p:nvPr/>
         </p:nvSpPr>
         <p:spPr>
           <a:xfrm>
-            <a:off x="2807208" y="3310128"/>
-            <a:ext cx="6583680" cy="548640"/>
+            <a:off x="1737360" y="3703320"/>
+            <a:ext cx="8714232" cy="685800"/>
           </a:xfrm>
           <a:prstGeom prst="rect">
             <a:avLst/>
@@ -8078,7 +6782,7 @@
               </a:lnSpc>
             </a:pPr>
             <a:r>
-              <a:rPr sz="2600" b="0" i="0">
+              <a:rPr sz="3000" b="1" i="0">
                 <a:solidFill>
                   <a:srgbClr val="1A2430"/>
                 </a:solidFill>
@@ -8091,21 +6795,21 @@
       </p:sp>
       <p:cxnSp>
         <p:nvCxnSpPr>
-          <p:cNvPr id="5" name="Connector 4"/>
+          <p:cNvPr id="4" name="Connector 3"/>
           <p:cNvCxnSpPr/>
           <p:nvPr/>
         </p:nvCxnSpPr>
         <p:spPr>
           <a:xfrm>
-            <a:off x="4636008" y="4041648"/>
-            <a:ext cx="2926080" cy="0"/>
+            <a:off x="5367528" y="4617720"/>
+            <a:ext cx="1463040" cy="0"/>
           </a:xfrm>
           <a:prstGeom prst="line">
             <a:avLst/>
           </a:prstGeom>
-          <a:ln w="9525">
+          <a:ln w="20320">
             <a:solidFill>
-              <a:srgbClr val="1A2430"/>
+              <a:srgbClr val="1F4E79"/>
             </a:solidFill>
           </a:ln>
         </p:spPr>
@@ -8142,51 +6846,16 @@
         <p:nvPr/>
       </p:nvGrpSpPr>
       <p:grpSpPr/>
-      <p:cxnSp>
-        <p:nvCxnSpPr>
-          <p:cNvPr id="2" name="Connector 1"/>
-          <p:cNvCxnSpPr/>
-          <p:nvPr/>
-        </p:nvCxnSpPr>
-        <p:spPr>
-          <a:xfrm>
-            <a:off x="4636008" y="2788920"/>
-            <a:ext cx="2926080" cy="0"/>
-          </a:xfrm>
-          <a:prstGeom prst="line">
-            <a:avLst/>
-          </a:prstGeom>
-          <a:ln w="9525">
-            <a:solidFill>
-              <a:srgbClr val="1A2430"/>
-            </a:solidFill>
-          </a:ln>
-        </p:spPr>
-        <p:style>
-          <a:lnRef idx="2">
-            <a:schemeClr val="accent1"/>
-          </a:lnRef>
-          <a:fillRef idx="0">
-            <a:schemeClr val="accent1"/>
-          </a:fillRef>
-          <a:effectRef idx="1">
-            <a:schemeClr val="accent1"/>
-          </a:effectRef>
-          <a:fontRef idx="minor">
-            <a:schemeClr val="tx1"/>
-          </a:fontRef>
-        </p:style>
-      </p:cxnSp>
-      <p:sp>
-        <p:nvSpPr>
-          <p:cNvPr id="3" name="TextBox 2"/>
+      <p:sp>
+        <p:nvSpPr>
+          <p:cNvPr id="2" name="TextBox 1"/>
           <p:cNvSpPr txBox="1"/>
           <p:nvPr/>
         </p:nvSpPr>
         <p:spPr>
           <a:xfrm>
-            <a:off x="4636008" y="2971800"/>
-            <a:ext cx="2926080" cy="365760"/>
+            <a:off x="1737360" y="685800"/>
+            <a:ext cx="8714232" cy="2926080"/>
           </a:xfrm>
           <a:prstGeom prst="rect">
             <a:avLst/>
@@ -8205,9 +6874,9 @@
               </a:lnSpc>
             </a:pPr>
             <a:r>
-              <a:rPr sz="1400" b="0" i="0">
-                <a:solidFill>
-                  <a:srgbClr val="55606B"/>
+              <a:rPr sz="17000" b="1" i="0">
+                <a:solidFill>
+                  <a:srgbClr val="ECF0F4"/>
                 </a:solidFill>
                 <a:latin typeface="Garamond"/>
               </a:rPr>
@@ -8218,14 +6887,14 @@
       </p:sp>
       <p:sp>
         <p:nvSpPr>
-          <p:cNvPr id="4" name="TextBox 3"/>
+          <p:cNvPr id="3" name="TextBox 2"/>
           <p:cNvSpPr txBox="1"/>
           <p:nvPr/>
         </p:nvSpPr>
         <p:spPr>
           <a:xfrm>
-            <a:off x="2807208" y="3310128"/>
-            <a:ext cx="6583680" cy="548640"/>
+            <a:off x="1737360" y="3703320"/>
+            <a:ext cx="8714232" cy="685800"/>
           </a:xfrm>
           <a:prstGeom prst="rect">
             <a:avLst/>
@@ -8244,7 +6913,7 @@
               </a:lnSpc>
             </a:pPr>
             <a:r>
-              <a:rPr sz="2600" b="0" i="0">
+              <a:rPr sz="3000" b="1" i="0">
                 <a:solidFill>
                   <a:srgbClr val="1A2430"/>
                 </a:solidFill>
@@ -8257,21 +6926,21 @@
       </p:sp>
       <p:cxnSp>
         <p:nvCxnSpPr>
-          <p:cNvPr id="5" name="Connector 4"/>
+          <p:cNvPr id="4" name="Connector 3"/>
           <p:cNvCxnSpPr/>
           <p:nvPr/>
         </p:nvCxnSpPr>
         <p:spPr>
           <a:xfrm>
-            <a:off x="4636008" y="4041648"/>
-            <a:ext cx="2926080" cy="0"/>
+            <a:off x="5367528" y="4617720"/>
+            <a:ext cx="1463040" cy="0"/>
           </a:xfrm>
           <a:prstGeom prst="line">
             <a:avLst/>
           </a:prstGeom>
-          <a:ln w="9525">
+          <a:ln w="20320">
             <a:solidFill>
-              <a:srgbClr val="1A2430"/>
+              <a:srgbClr val="1F4E79"/>
             </a:solidFill>
           </a:ln>
         </p:spPr>
@@ -8308,51 +6977,16 @@
         <p:nvPr/>
       </p:nvGrpSpPr>
       <p:grpSpPr/>
-      <p:cxnSp>
-        <p:nvCxnSpPr>
-          <p:cNvPr id="2" name="Connector 1"/>
-          <p:cNvCxnSpPr/>
-          <p:nvPr/>
-        </p:nvCxnSpPr>
-        <p:spPr>
-          <a:xfrm>
-            <a:off x="4636008" y="2788920"/>
-            <a:ext cx="2926080" cy="0"/>
-          </a:xfrm>
-          <a:prstGeom prst="line">
-            <a:avLst/>
-          </a:prstGeom>
-          <a:ln w="9525">
-            <a:solidFill>
-              <a:srgbClr val="1A2430"/>
-            </a:solidFill>
-          </a:ln>
-        </p:spPr>
-        <p:style>
-          <a:lnRef idx="2">
-            <a:schemeClr val="accent1"/>
-          </a:lnRef>
-          <a:fillRef idx="0">
-            <a:schemeClr val="accent1"/>
-          </a:fillRef>
-          <a:effectRef idx="1">
-            <a:schemeClr val="accent1"/>
-          </a:effectRef>
-          <a:fontRef idx="minor">
-            <a:schemeClr val="tx1"/>
-          </a:fontRef>
-        </p:style>
-      </p:cxnSp>
-      <p:sp>
-        <p:nvSpPr>
-          <p:cNvPr id="3" name="TextBox 2"/>
+      <p:sp>
+        <p:nvSpPr>
+          <p:cNvPr id="2" name="TextBox 1"/>
           <p:cNvSpPr txBox="1"/>
           <p:nvPr/>
         </p:nvSpPr>
         <p:spPr>
           <a:xfrm>
-            <a:off x="4636008" y="2971800"/>
-            <a:ext cx="2926080" cy="365760"/>
+            <a:off x="1737360" y="685800"/>
+            <a:ext cx="8714232" cy="2926080"/>
           </a:xfrm>
           <a:prstGeom prst="rect">
             <a:avLst/>
@@ -8371,9 +7005,9 @@
               </a:lnSpc>
             </a:pPr>
             <a:r>
-              <a:rPr sz="1400" b="0" i="0">
-                <a:solidFill>
-                  <a:srgbClr val="55606B"/>
+              <a:rPr sz="17000" b="1" i="0">
+                <a:solidFill>
+                  <a:srgbClr val="ECF0F4"/>
                 </a:solidFill>
                 <a:latin typeface="Garamond"/>
               </a:rPr>
@@ -8384,14 +7018,14 @@
       </p:sp>
       <p:sp>
         <p:nvSpPr>
-          <p:cNvPr id="4" name="TextBox 3"/>
+          <p:cNvPr id="3" name="TextBox 2"/>
           <p:cNvSpPr txBox="1"/>
           <p:nvPr/>
         </p:nvSpPr>
         <p:spPr>
           <a:xfrm>
-            <a:off x="2807208" y="3310128"/>
-            <a:ext cx="6583680" cy="548640"/>
+            <a:off x="1737360" y="3703320"/>
+            <a:ext cx="8714232" cy="685800"/>
           </a:xfrm>
           <a:prstGeom prst="rect">
             <a:avLst/>
@@ -8410,7 +7044,7 @@
               </a:lnSpc>
             </a:pPr>
             <a:r>
-              <a:rPr sz="2600" b="0" i="0">
+              <a:rPr sz="3000" b="1" i="0">
                 <a:solidFill>
                   <a:srgbClr val="1A2430"/>
                 </a:solidFill>
@@ -8423,21 +7057,21 @@
       </p:sp>
       <p:cxnSp>
         <p:nvCxnSpPr>
-          <p:cNvPr id="5" name="Connector 4"/>
+          <p:cNvPr id="4" name="Connector 3"/>
           <p:cNvCxnSpPr/>
           <p:nvPr/>
         </p:nvCxnSpPr>
         <p:spPr>
           <a:xfrm>
-            <a:off x="4636008" y="4041648"/>
-            <a:ext cx="2926080" cy="0"/>
+            <a:off x="5367528" y="4617720"/>
+            <a:ext cx="1463040" cy="0"/>
           </a:xfrm>
           <a:prstGeom prst="line">
             <a:avLst/>
           </a:prstGeom>
-          <a:ln w="9525">
+          <a:ln w="20320">
             <a:solidFill>
-              <a:srgbClr val="1A2430"/>
+              <a:srgbClr val="1F4E79"/>
             </a:solidFill>
           </a:ln>
         </p:spPr>
@@ -11141,7 +9775,7 @@
         <p:spPr>
           <a:xfrm>
             <a:off x="822960" y="1417320"/>
-            <a:ext cx="3017520" cy="365760"/>
+            <a:ext cx="2834640" cy="365760"/>
           </a:xfrm>
           <a:prstGeom prst="rect">
             <a:avLst/>
@@ -11179,8 +9813,8 @@
         </p:nvSpPr>
         <p:spPr>
           <a:xfrm>
-            <a:off x="3931920" y="1417320"/>
-            <a:ext cx="5852160" cy="365760"/>
+            <a:off x="3794760" y="1417320"/>
+            <a:ext cx="1463040" cy="365760"/>
           </a:xfrm>
           <a:prstGeom prst="rect">
             <a:avLst/>
@@ -11205,7 +9839,7 @@
                 </a:solidFill>
                 <a:latin typeface="Garamond"/>
               </a:rPr>
-              <a:t>In words</a:t>
+              <a:t>Years</a:t>
             </a:r>
           </a:p>
         </p:txBody>
@@ -11218,8 +9852,8 @@
         </p:nvSpPr>
         <p:spPr>
           <a:xfrm>
-            <a:off x="9966960" y="1417320"/>
-            <a:ext cx="1371600" cy="365760"/>
+            <a:off x="5349240" y="1417320"/>
+            <a:ext cx="4480560" cy="365760"/>
           </a:xfrm>
           <a:prstGeom prst="rect">
             <a:avLst/>
@@ -11244,6 +9878,45 @@
                 </a:solidFill>
                 <a:latin typeface="Garamond"/>
               </a:rPr>
+              <a:t>In words</a:t>
+            </a:r>
+          </a:p>
+        </p:txBody>
+      </p:sp>
+      <p:sp>
+        <p:nvSpPr>
+          <p:cNvPr id="7" name="TextBox 6"/>
+          <p:cNvSpPr txBox="1"/>
+          <p:nvPr/>
+        </p:nvSpPr>
+        <p:spPr>
+          <a:xfrm>
+            <a:off x="9966960" y="1417320"/>
+            <a:ext cx="1371600" cy="365760"/>
+          </a:xfrm>
+          <a:prstGeom prst="rect">
+            <a:avLst/>
+          </a:prstGeom>
+          <a:noFill/>
+        </p:spPr>
+        <p:txBody>
+          <a:bodyPr wrap="square" lIns="0" rIns="0" tIns="0" bIns="0">
+            <a:spAutoFit/>
+          </a:bodyPr>
+          <a:lstStyle/>
+          <a:p>
+            <a:pPr algn="l">
+              <a:lnSpc>
+                <a:spcPct val="100000"/>
+              </a:lnSpc>
+            </a:pPr>
+            <a:r>
+              <a:rPr sz="1250" b="1" i="0">
+                <a:solidFill>
+                  <a:srgbClr val="1A2430"/>
+                </a:solidFill>
+                <a:latin typeface="Garamond"/>
+              </a:rPr>
               <a:t>Rate</a:t>
             </a:r>
           </a:p>
@@ -11251,7 +9924,7 @@
       </p:sp>
       <p:cxnSp>
         <p:nvCxnSpPr>
-          <p:cNvPr id="7" name="Connector 6"/>
+          <p:cNvPr id="8" name="Connector 7"/>
           <p:cNvCxnSpPr/>
           <p:nvPr/>
         </p:nvCxnSpPr>
@@ -11286,14 +9959,14 @@
       </p:cxnSp>
       <p:sp>
         <p:nvSpPr>
-          <p:cNvPr id="8" name="TextBox 7"/>
+          <p:cNvPr id="9" name="TextBox 8"/>
           <p:cNvSpPr txBox="1"/>
           <p:nvPr/>
         </p:nvSpPr>
         <p:spPr>
           <a:xfrm>
             <a:off x="822960" y="1993392"/>
-            <a:ext cx="3017520" cy="640080"/>
+            <a:ext cx="2834640" cy="640080"/>
           </a:xfrm>
           <a:prstGeom prst="rect">
             <a:avLst/>
@@ -11325,14 +9998,14 @@
       </p:sp>
       <p:sp>
         <p:nvSpPr>
-          <p:cNvPr id="9" name="TextBox 8"/>
+          <p:cNvPr id="10" name="TextBox 9"/>
           <p:cNvSpPr txBox="1"/>
           <p:nvPr/>
         </p:nvSpPr>
         <p:spPr>
           <a:xfrm>
-            <a:off x="3931920" y="1993392"/>
-            <a:ext cx="5852160" cy="640080"/>
+            <a:off x="3794760" y="1993392"/>
+            <a:ext cx="1463040" cy="640080"/>
           </a:xfrm>
           <a:prstGeom prst="rect">
             <a:avLst/>
@@ -11353,6 +10026,45 @@
             <a:r>
               <a:rPr sz="1250" b="0" i="0">
                 <a:solidFill>
+                  <a:srgbClr val="55606B"/>
+                </a:solidFill>
+                <a:latin typeface="Garamond"/>
+              </a:rPr>
+              <a:t>1997–2024</a:t>
+            </a:r>
+          </a:p>
+        </p:txBody>
+      </p:sp>
+      <p:sp>
+        <p:nvSpPr>
+          <p:cNvPr id="11" name="TextBox 10"/>
+          <p:cNvSpPr txBox="1"/>
+          <p:nvPr/>
+        </p:nvSpPr>
+        <p:spPr>
+          <a:xfrm>
+            <a:off x="5349240" y="1993392"/>
+            <a:ext cx="4480560" cy="640080"/>
+          </a:xfrm>
+          <a:prstGeom prst="rect">
+            <a:avLst/>
+          </a:prstGeom>
+          <a:noFill/>
+        </p:spPr>
+        <p:txBody>
+          <a:bodyPr wrap="square" lIns="0" rIns="0" tIns="0" bIns="0">
+            <a:spAutoFit/>
+          </a:bodyPr>
+          <a:lstStyle/>
+          <a:p>
+            <a:pPr algn="l">
+              <a:lnSpc>
+                <a:spcPct val="100000"/>
+              </a:lnSpc>
+            </a:pPr>
+            <a:r>
+              <a:rPr sz="1250" b="0" i="0">
+                <a:solidFill>
                   <a:srgbClr val="1A2430"/>
                 </a:solidFill>
                 <a:latin typeface="Garamond"/>
@@ -11364,7 +10076,7 @@
       </p:sp>
       <p:sp>
         <p:nvSpPr>
-          <p:cNvPr id="10" name="TextBox 9"/>
+          <p:cNvPr id="12" name="TextBox 11"/>
           <p:cNvSpPr txBox="1"/>
           <p:nvPr/>
         </p:nvSpPr>
@@ -11403,14 +10115,14 @@
       </p:sp>
       <p:sp>
         <p:nvSpPr>
-          <p:cNvPr id="11" name="TextBox 10"/>
+          <p:cNvPr id="13" name="TextBox 12"/>
           <p:cNvSpPr txBox="1"/>
           <p:nvPr/>
         </p:nvSpPr>
         <p:spPr>
           <a:xfrm>
             <a:off x="822960" y="2651760"/>
-            <a:ext cx="3017520" cy="640080"/>
+            <a:ext cx="2834640" cy="640080"/>
           </a:xfrm>
           <a:prstGeom prst="rect">
             <a:avLst/>
@@ -11442,14 +10154,14 @@
       </p:sp>
       <p:sp>
         <p:nvSpPr>
-          <p:cNvPr id="12" name="TextBox 11"/>
+          <p:cNvPr id="14" name="TextBox 13"/>
           <p:cNvSpPr txBox="1"/>
           <p:nvPr/>
         </p:nvSpPr>
         <p:spPr>
           <a:xfrm>
-            <a:off x="3931920" y="2651760"/>
-            <a:ext cx="5852160" cy="640080"/>
+            <a:off x="3794760" y="2651760"/>
+            <a:ext cx="1463040" cy="640080"/>
           </a:xfrm>
           <a:prstGeom prst="rect">
             <a:avLst/>
@@ -11470,6 +10182,45 @@
             <a:r>
               <a:rPr sz="1250" b="0" i="0">
                 <a:solidFill>
+                  <a:srgbClr val="55606B"/>
+                </a:solidFill>
+                <a:latin typeface="Garamond"/>
+              </a:rPr>
+              <a:t>2021–2023</a:t>
+            </a:r>
+          </a:p>
+        </p:txBody>
+      </p:sp>
+      <p:sp>
+        <p:nvSpPr>
+          <p:cNvPr id="15" name="TextBox 14"/>
+          <p:cNvSpPr txBox="1"/>
+          <p:nvPr/>
+        </p:nvSpPr>
+        <p:spPr>
+          <a:xfrm>
+            <a:off x="5349240" y="2651760"/>
+            <a:ext cx="4480560" cy="640080"/>
+          </a:xfrm>
+          <a:prstGeom prst="rect">
+            <a:avLst/>
+          </a:prstGeom>
+          <a:noFill/>
+        </p:spPr>
+        <p:txBody>
+          <a:bodyPr wrap="square" lIns="0" rIns="0" tIns="0" bIns="0">
+            <a:spAutoFit/>
+          </a:bodyPr>
+          <a:lstStyle/>
+          <a:p>
+            <a:pPr algn="l">
+              <a:lnSpc>
+                <a:spcPct val="100000"/>
+              </a:lnSpc>
+            </a:pPr>
+            <a:r>
+              <a:rPr sz="1250" b="0" i="0">
+                <a:solidFill>
                   <a:srgbClr val="1A2430"/>
                 </a:solidFill>
                 <a:latin typeface="Garamond"/>
@@ -11481,7 +10232,7 @@
       </p:sp>
       <p:sp>
         <p:nvSpPr>
-          <p:cNvPr id="13" name="TextBox 12"/>
+          <p:cNvPr id="16" name="TextBox 15"/>
           <p:cNvSpPr txBox="1"/>
           <p:nvPr/>
         </p:nvSpPr>
@@ -11520,14 +10271,14 @@
       </p:sp>
       <p:sp>
         <p:nvSpPr>
-          <p:cNvPr id="14" name="TextBox 13"/>
+          <p:cNvPr id="17" name="TextBox 16"/>
           <p:cNvSpPr txBox="1"/>
           <p:nvPr/>
         </p:nvSpPr>
         <p:spPr>
           <a:xfrm>
             <a:off x="822960" y="3310128"/>
-            <a:ext cx="3017520" cy="640080"/>
+            <a:ext cx="2834640" cy="640080"/>
           </a:xfrm>
           <a:prstGeom prst="rect">
             <a:avLst/>
@@ -11559,14 +10310,14 @@
       </p:sp>
       <p:sp>
         <p:nvSpPr>
-          <p:cNvPr id="15" name="TextBox 14"/>
+          <p:cNvPr id="18" name="TextBox 17"/>
           <p:cNvSpPr txBox="1"/>
           <p:nvPr/>
         </p:nvSpPr>
         <p:spPr>
           <a:xfrm>
-            <a:off x="3931920" y="3310128"/>
-            <a:ext cx="5852160" cy="640080"/>
+            <a:off x="3794760" y="3310128"/>
+            <a:ext cx="1463040" cy="640080"/>
           </a:xfrm>
           <a:prstGeom prst="rect">
             <a:avLst/>
@@ -11587,6 +10338,45 @@
             <a:r>
               <a:rPr sz="1250" b="0" i="0">
                 <a:solidFill>
+                  <a:srgbClr val="55606B"/>
+                </a:solidFill>
+                <a:latin typeface="Garamond"/>
+              </a:rPr>
+              <a:t>2005–2024</a:t>
+            </a:r>
+          </a:p>
+        </p:txBody>
+      </p:sp>
+      <p:sp>
+        <p:nvSpPr>
+          <p:cNvPr id="19" name="TextBox 18"/>
+          <p:cNvSpPr txBox="1"/>
+          <p:nvPr/>
+        </p:nvSpPr>
+        <p:spPr>
+          <a:xfrm>
+            <a:off x="5349240" y="3310128"/>
+            <a:ext cx="4480560" cy="640080"/>
+          </a:xfrm>
+          <a:prstGeom prst="rect">
+            <a:avLst/>
+          </a:prstGeom>
+          <a:noFill/>
+        </p:spPr>
+        <p:txBody>
+          <a:bodyPr wrap="square" lIns="0" rIns="0" tIns="0" bIns="0">
+            <a:spAutoFit/>
+          </a:bodyPr>
+          <a:lstStyle/>
+          <a:p>
+            <a:pPr algn="l">
+              <a:lnSpc>
+                <a:spcPct val="100000"/>
+              </a:lnSpc>
+            </a:pPr>
+            <a:r>
+              <a:rPr sz="1250" b="0" i="0">
+                <a:solidFill>
                   <a:srgbClr val="1A2430"/>
                 </a:solidFill>
                 <a:latin typeface="Garamond"/>
@@ -11598,7 +10388,7 @@
       </p:sp>
       <p:sp>
         <p:nvSpPr>
-          <p:cNvPr id="16" name="TextBox 15"/>
+          <p:cNvPr id="20" name="TextBox 19"/>
           <p:cNvSpPr txBox="1"/>
           <p:nvPr/>
         </p:nvSpPr>
@@ -11637,14 +10427,14 @@
       </p:sp>
       <p:sp>
         <p:nvSpPr>
-          <p:cNvPr id="17" name="TextBox 16"/>
+          <p:cNvPr id="21" name="TextBox 20"/>
           <p:cNvSpPr txBox="1"/>
           <p:nvPr/>
         </p:nvSpPr>
         <p:spPr>
           <a:xfrm>
             <a:off x="822960" y="3968496"/>
-            <a:ext cx="3017520" cy="640080"/>
+            <a:ext cx="2834640" cy="640080"/>
           </a:xfrm>
           <a:prstGeom prst="rect">
             <a:avLst/>
@@ -11676,14 +10466,14 @@
       </p:sp>
       <p:sp>
         <p:nvSpPr>
-          <p:cNvPr id="18" name="TextBox 17"/>
+          <p:cNvPr id="22" name="TextBox 21"/>
           <p:cNvSpPr txBox="1"/>
           <p:nvPr/>
         </p:nvSpPr>
         <p:spPr>
           <a:xfrm>
-            <a:off x="3931920" y="3968496"/>
-            <a:ext cx="5852160" cy="640080"/>
+            <a:off x="3794760" y="3968496"/>
+            <a:ext cx="1463040" cy="640080"/>
           </a:xfrm>
           <a:prstGeom prst="rect">
             <a:avLst/>
@@ -11704,6 +10494,45 @@
             <a:r>
               <a:rPr sz="1250" b="0" i="0">
                 <a:solidFill>
+                  <a:srgbClr val="55606B"/>
+                </a:solidFill>
+                <a:latin typeface="Garamond"/>
+              </a:rPr>
+              <a:t>2005–2024</a:t>
+            </a:r>
+          </a:p>
+        </p:txBody>
+      </p:sp>
+      <p:sp>
+        <p:nvSpPr>
+          <p:cNvPr id="23" name="TextBox 22"/>
+          <p:cNvSpPr txBox="1"/>
+          <p:nvPr/>
+        </p:nvSpPr>
+        <p:spPr>
+          <a:xfrm>
+            <a:off x="5349240" y="3968496"/>
+            <a:ext cx="4480560" cy="640080"/>
+          </a:xfrm>
+          <a:prstGeom prst="rect">
+            <a:avLst/>
+          </a:prstGeom>
+          <a:noFill/>
+        </p:spPr>
+        <p:txBody>
+          <a:bodyPr wrap="square" lIns="0" rIns="0" tIns="0" bIns="0">
+            <a:spAutoFit/>
+          </a:bodyPr>
+          <a:lstStyle/>
+          <a:p>
+            <a:pPr algn="l">
+              <a:lnSpc>
+                <a:spcPct val="100000"/>
+              </a:lnSpc>
+            </a:pPr>
+            <a:r>
+              <a:rPr sz="1250" b="0" i="0">
+                <a:solidFill>
                   <a:srgbClr val="1A2430"/>
                 </a:solidFill>
                 <a:latin typeface="Garamond"/>
@@ -11715,7 +10544,7 @@
       </p:sp>
       <p:sp>
         <p:nvSpPr>
-          <p:cNvPr id="19" name="TextBox 18"/>
+          <p:cNvPr id="24" name="TextBox 23"/>
           <p:cNvSpPr txBox="1"/>
           <p:nvPr/>
         </p:nvSpPr>
@@ -11754,14 +10583,14 @@
       </p:sp>
       <p:sp>
         <p:nvSpPr>
-          <p:cNvPr id="20" name="TextBox 19"/>
+          <p:cNvPr id="25" name="TextBox 24"/>
           <p:cNvSpPr txBox="1"/>
           <p:nvPr/>
         </p:nvSpPr>
         <p:spPr>
           <a:xfrm>
             <a:off x="822960" y="4626864"/>
-            <a:ext cx="3017520" cy="640080"/>
+            <a:ext cx="2834640" cy="640080"/>
           </a:xfrm>
           <a:prstGeom prst="rect">
             <a:avLst/>
@@ -11793,14 +10622,14 @@
       </p:sp>
       <p:sp>
         <p:nvSpPr>
-          <p:cNvPr id="21" name="TextBox 20"/>
+          <p:cNvPr id="26" name="TextBox 25"/>
           <p:cNvSpPr txBox="1"/>
           <p:nvPr/>
         </p:nvSpPr>
         <p:spPr>
           <a:xfrm>
-            <a:off x="3931920" y="4626864"/>
-            <a:ext cx="5852160" cy="640080"/>
+            <a:off x="3794760" y="4626864"/>
+            <a:ext cx="1463040" cy="640080"/>
           </a:xfrm>
           <a:prstGeom prst="rect">
             <a:avLst/>
@@ -11821,6 +10650,45 @@
             <a:r>
               <a:rPr sz="1250" b="0" i="0">
                 <a:solidFill>
+                  <a:srgbClr val="55606B"/>
+                </a:solidFill>
+                <a:latin typeface="Garamond"/>
+              </a:rPr>
+              <a:t>2005–2024</a:t>
+            </a:r>
+          </a:p>
+        </p:txBody>
+      </p:sp>
+      <p:sp>
+        <p:nvSpPr>
+          <p:cNvPr id="27" name="TextBox 26"/>
+          <p:cNvSpPr txBox="1"/>
+          <p:nvPr/>
+        </p:nvSpPr>
+        <p:spPr>
+          <a:xfrm>
+            <a:off x="5349240" y="4626864"/>
+            <a:ext cx="4480560" cy="640080"/>
+          </a:xfrm>
+          <a:prstGeom prst="rect">
+            <a:avLst/>
+          </a:prstGeom>
+          <a:noFill/>
+        </p:spPr>
+        <p:txBody>
+          <a:bodyPr wrap="square" lIns="0" rIns="0" tIns="0" bIns="0">
+            <a:spAutoFit/>
+          </a:bodyPr>
+          <a:lstStyle/>
+          <a:p>
+            <a:pPr algn="l">
+              <a:lnSpc>
+                <a:spcPct val="100000"/>
+              </a:lnSpc>
+            </a:pPr>
+            <a:r>
+              <a:rPr sz="1250" b="0" i="0">
+                <a:solidFill>
                   <a:srgbClr val="1A2430"/>
                 </a:solidFill>
                 <a:latin typeface="Garamond"/>
@@ -11832,7 +10700,7 @@
       </p:sp>
       <p:sp>
         <p:nvSpPr>
-          <p:cNvPr id="22" name="TextBox 21"/>
+          <p:cNvPr id="28" name="TextBox 27"/>
           <p:cNvSpPr txBox="1"/>
           <p:nvPr/>
         </p:nvSpPr>
@@ -11871,14 +10739,14 @@
       </p:sp>
       <p:sp>
         <p:nvSpPr>
-          <p:cNvPr id="23" name="TextBox 22"/>
+          <p:cNvPr id="29" name="TextBox 28"/>
           <p:cNvSpPr txBox="1"/>
           <p:nvPr/>
         </p:nvSpPr>
         <p:spPr>
           <a:xfrm>
             <a:off x="822960" y="5285231"/>
-            <a:ext cx="3017520" cy="640080"/>
+            <a:ext cx="2834640" cy="640080"/>
           </a:xfrm>
           <a:prstGeom prst="rect">
             <a:avLst/>
@@ -11910,14 +10778,14 @@
       </p:sp>
       <p:sp>
         <p:nvSpPr>
-          <p:cNvPr id="24" name="TextBox 23"/>
+          <p:cNvPr id="30" name="TextBox 29"/>
           <p:cNvSpPr txBox="1"/>
           <p:nvPr/>
         </p:nvSpPr>
         <p:spPr>
           <a:xfrm>
-            <a:off x="3931920" y="5285231"/>
-            <a:ext cx="5852160" cy="640080"/>
+            <a:off x="3794760" y="5285231"/>
+            <a:ext cx="1463040" cy="640080"/>
           </a:xfrm>
           <a:prstGeom prst="rect">
             <a:avLst/>
@@ -11938,18 +10806,57 @@
             <a:r>
               <a:rPr sz="1250" b="0" i="0">
                 <a:solidFill>
-                  <a:srgbClr val="1A2430"/>
+                  <a:srgbClr val="55606B"/>
                 </a:solidFill>
                 <a:latin typeface="Garamond"/>
               </a:rPr>
-              <a:t>school rosters re-surveyed the following fall; every four to five years</a:t>
+              <a:t>1988–2022</a:t>
             </a:r>
           </a:p>
         </p:txBody>
       </p:sp>
       <p:sp>
         <p:nvSpPr>
-          <p:cNvPr id="25" name="TextBox 24"/>
+          <p:cNvPr id="31" name="TextBox 30"/>
+          <p:cNvSpPr txBox="1"/>
+          <p:nvPr/>
+        </p:nvSpPr>
+        <p:spPr>
+          <a:xfrm>
+            <a:off x="5349240" y="5285231"/>
+            <a:ext cx="4480560" cy="640080"/>
+          </a:xfrm>
+          <a:prstGeom prst="rect">
+            <a:avLst/>
+          </a:prstGeom>
+          <a:noFill/>
+        </p:spPr>
+        <p:txBody>
+          <a:bodyPr wrap="square" lIns="0" rIns="0" tIns="0" bIns="0">
+            <a:spAutoFit/>
+          </a:bodyPr>
+          <a:lstStyle/>
+          <a:p>
+            <a:pPr algn="l">
+              <a:lnSpc>
+                <a:spcPct val="100000"/>
+              </a:lnSpc>
+            </a:pPr>
+            <a:r>
+              <a:rPr sz="1250" b="0" i="0">
+                <a:solidFill>
+                  <a:srgbClr val="1A2430"/>
+                </a:solidFill>
+                <a:latin typeface="Garamond"/>
+              </a:rPr>
+              <a:t>school rosters re-surveyed the following fall; eight waves</a:t>
+            </a:r>
+          </a:p>
+        </p:txBody>
+      </p:sp>
+      <p:sp>
+        <p:nvSpPr>
+          <p:cNvPr id="32" name="TextBox 31"/>
           <p:cNvSpPr txBox="1"/>
           <p:nvPr/>
         </p:nvSpPr>
@@ -11981,14 +10888,14 @@
                 </a:solidFill>
                 <a:latin typeface="Garamond"/>
               </a:rPr>
-              <a:t>5.1 – 8.4</a:t>
+              <a:t>8.0</a:t>
             </a:r>
           </a:p>
         </p:txBody>
       </p:sp>
       <p:cxnSp>
         <p:nvCxnSpPr>
-          <p:cNvPr id="26" name="Connector 25"/>
+          <p:cNvPr id="33" name="Connector 32"/>
           <p:cNvCxnSpPr/>
           <p:nvPr/>
         </p:nvCxnSpPr>
@@ -12023,7 +10930,7 @@
       </p:cxnSp>
       <p:sp>
         <p:nvSpPr>
-          <p:cNvPr id="27" name="TextBox 26"/>
+          <p:cNvPr id="34" name="TextBox 33"/>
           <p:cNvSpPr txBox="1"/>
           <p:nvPr/>
         </p:nvSpPr>
@@ -12055,7 +10962,7 @@
                 </a:solidFill>
                 <a:latin typeface="Garamond"/>
               </a:rPr>
-              <a:t>Same records throughout; only the definition changes. Annual average, percent of teachers.</a:t>
+              <a:t>Same records throughout; only the definition changes. Rate: annual average over the years shown; for the NCES, the latest wave (2021–22).</a:t>
             </a:r>
           </a:p>
         </p:txBody>
@@ -12117,24 +11024,30 @@
           </a:p>
         </p:txBody>
       </p:sp>
-      <p:graphicFrame>
-        <p:nvGraphicFramePr>
-          <p:cNvPr id="3" name="Chart 2"/>
-          <p:cNvGraphicFramePr>
-            <a:graphicFrameLocks noGrp="1"/>
-          </p:cNvGraphicFramePr>
-          <p:nvPr/>
-        </p:nvGraphicFramePr>
-        <p:xfrm>
-          <a:off x="640080" y="1051560"/>
-          <a:ext cx="10972800" cy="5212080"/>
-        </p:xfrm>
-        <a:graphic>
-          <a:graphicData uri="http://schemas.openxmlformats.org/drawingml/2006/chart">
-            <c:chart xmlns:c="http://schemas.openxmlformats.org/drawingml/2006/chart" r:id="rId2"/>
-          </a:graphicData>
-        </a:graphic>
-      </p:graphicFrame>
+      <p:pic>
+        <p:nvPicPr>
+          <p:cNvPr id="3" name="Picture 2" descr="v_allseries.png"/>
+          <p:cNvPicPr>
+            <a:picLocks noChangeAspect="1"/>
+          </p:cNvPicPr>
+          <p:nvPr/>
+        </p:nvPicPr>
+        <p:blipFill>
+          <a:blip r:embed="rId2"/>
+          <a:stretch>
+            <a:fillRect/>
+          </a:stretch>
+        </p:blipFill>
+        <p:spPr>
+          <a:xfrm>
+            <a:off x="594360" y="1097280"/>
+            <a:ext cx="11018520" cy="5418944"/>
+          </a:xfrm>
+          <a:prstGeom prst="rect">
+            <a:avLst/>
+          </a:prstGeom>
+        </p:spPr>
+      </p:pic>
     </p:spTree>
   </p:cSld>
   <p:clrMapOvr>

</xml_diff>